<commit_message>
Just modified Brachify png
</commit_message>
<xml_diff>
--- a/src/windows/splashscreen/brachify_splash.pptx
+++ b/src/windows/splashscreen/brachify_splash.pptx
@@ -2713,7 +2713,7 @@
           <a:p>
             <a:fld id="{0D039BA5-E807-4E9D-A087-F89B6691E655}" type="datetimeFigureOut">
               <a:rPr lang="en-CA" smtClean="0"/>
-              <a:t>2023-11-02</a:t>
+              <a:t>24-May-2024</a:t>
             </a:fld>
             <a:endParaRPr lang="en-CA"/>
           </a:p>
@@ -2883,7 +2883,7 @@
           <a:p>
             <a:fld id="{0D039BA5-E807-4E9D-A087-F89B6691E655}" type="datetimeFigureOut">
               <a:rPr lang="en-CA" smtClean="0"/>
-              <a:t>2023-11-02</a:t>
+              <a:t>24-May-2024</a:t>
             </a:fld>
             <a:endParaRPr lang="en-CA"/>
           </a:p>
@@ -3063,7 +3063,7 @@
           <a:p>
             <a:fld id="{0D039BA5-E807-4E9D-A087-F89B6691E655}" type="datetimeFigureOut">
               <a:rPr lang="en-CA" smtClean="0"/>
-              <a:t>2023-11-02</a:t>
+              <a:t>24-May-2024</a:t>
             </a:fld>
             <a:endParaRPr lang="en-CA"/>
           </a:p>
@@ -3233,7 +3233,7 @@
           <a:p>
             <a:fld id="{0D039BA5-E807-4E9D-A087-F89B6691E655}" type="datetimeFigureOut">
               <a:rPr lang="en-CA" smtClean="0"/>
-              <a:t>2023-11-02</a:t>
+              <a:t>24-May-2024</a:t>
             </a:fld>
             <a:endParaRPr lang="en-CA"/>
           </a:p>
@@ -3479,7 +3479,7 @@
           <a:p>
             <a:fld id="{0D039BA5-E807-4E9D-A087-F89B6691E655}" type="datetimeFigureOut">
               <a:rPr lang="en-CA" smtClean="0"/>
-              <a:t>2023-11-02</a:t>
+              <a:t>24-May-2024</a:t>
             </a:fld>
             <a:endParaRPr lang="en-CA"/>
           </a:p>
@@ -3711,7 +3711,7 @@
           <a:p>
             <a:fld id="{0D039BA5-E807-4E9D-A087-F89B6691E655}" type="datetimeFigureOut">
               <a:rPr lang="en-CA" smtClean="0"/>
-              <a:t>2023-11-02</a:t>
+              <a:t>24-May-2024</a:t>
             </a:fld>
             <a:endParaRPr lang="en-CA"/>
           </a:p>
@@ -4078,7 +4078,7 @@
           <a:p>
             <a:fld id="{0D039BA5-E807-4E9D-A087-F89B6691E655}" type="datetimeFigureOut">
               <a:rPr lang="en-CA" smtClean="0"/>
-              <a:t>2023-11-02</a:t>
+              <a:t>24-May-2024</a:t>
             </a:fld>
             <a:endParaRPr lang="en-CA"/>
           </a:p>
@@ -4196,7 +4196,7 @@
           <a:p>
             <a:fld id="{0D039BA5-E807-4E9D-A087-F89B6691E655}" type="datetimeFigureOut">
               <a:rPr lang="en-CA" smtClean="0"/>
-              <a:t>2023-11-02</a:t>
+              <a:t>24-May-2024</a:t>
             </a:fld>
             <a:endParaRPr lang="en-CA"/>
           </a:p>
@@ -4291,7 +4291,7 @@
           <a:p>
             <a:fld id="{0D039BA5-E807-4E9D-A087-F89B6691E655}" type="datetimeFigureOut">
               <a:rPr lang="en-CA" smtClean="0"/>
-              <a:t>2023-11-02</a:t>
+              <a:t>24-May-2024</a:t>
             </a:fld>
             <a:endParaRPr lang="en-CA"/>
           </a:p>
@@ -4568,7 +4568,7 @@
           <a:p>
             <a:fld id="{0D039BA5-E807-4E9D-A087-F89B6691E655}" type="datetimeFigureOut">
               <a:rPr lang="en-CA" smtClean="0"/>
-              <a:t>2023-11-02</a:t>
+              <a:t>24-May-2024</a:t>
             </a:fld>
             <a:endParaRPr lang="en-CA"/>
           </a:p>
@@ -4821,7 +4821,7 @@
           <a:p>
             <a:fld id="{0D039BA5-E807-4E9D-A087-F89B6691E655}" type="datetimeFigureOut">
               <a:rPr lang="en-CA" smtClean="0"/>
-              <a:t>2023-11-02</a:t>
+              <a:t>24-May-2024</a:t>
             </a:fld>
             <a:endParaRPr lang="en-CA"/>
           </a:p>
@@ -5034,7 +5034,7 @@
           <a:p>
             <a:fld id="{0D039BA5-E807-4E9D-A087-F89B6691E655}" type="datetimeFigureOut">
               <a:rPr lang="en-CA" smtClean="0"/>
-              <a:t>2023-11-02</a:t>
+              <a:t>24-May-2024</a:t>
             </a:fld>
             <a:endParaRPr lang="en-CA"/>
           </a:p>
@@ -6735,41 +6735,6 @@
       </p:sp>
       <p:sp>
         <p:nvSpPr>
-          <p:cNvPr id="2" name="TextBox 1"/>
-          <p:cNvSpPr txBox="1"/>
-          <p:nvPr/>
-        </p:nvSpPr>
-        <p:spPr>
-          <a:xfrm>
-            <a:off x="8199120" y="6380285"/>
-            <a:ext cx="3992881" cy="461665"/>
-          </a:xfrm>
-          <a:prstGeom prst="rect">
-            <a:avLst/>
-          </a:prstGeom>
-          <a:noFill/>
-        </p:spPr>
-        <p:txBody>
-          <a:bodyPr wrap="square" rtlCol="0">
-            <a:spAutoFit/>
-          </a:bodyPr>
-          <a:lstStyle/>
-          <a:p>
-            <a:r>
-              <a:rPr lang="en-CA" sz="2400" dirty="0">
-                <a:solidFill>
-                  <a:schemeClr val="accent1">
-                    <a:lumMod val="50000"/>
-                  </a:schemeClr>
-                </a:solidFill>
-              </a:rPr>
-              <a:t>by nsmela and michael kudla</a:t>
-            </a:r>
-          </a:p>
-        </p:txBody>
-      </p:sp>
-      <p:sp>
-        <p:nvSpPr>
           <p:cNvPr id="3" name="TextBox 2">
             <a:extLst>
               <a:ext uri="{FF2B5EF4-FFF2-40B4-BE49-F238E27FC236}">

</xml_diff>